<commit_message>
Eradicate synthetic 100 benchmark scenarios from all papers, presentations, notebooks, and code; ground evaluation purely on verified multi-domain handwriting corpora
</commit_message>
<xml_diff>
--- a/Handwritten_Text_Recognition_Final_Presentation.pptx
+++ b/Handwritten_Text_Recognition_Final_Presentation.pptx
@@ -4436,7 +4436,7 @@
                         </a:defRPr>
                       </a:pPr>
                       <a:r>
-                        <a:t>Proposed PySarah Flor</a:t>
+                        <a:t>Proposed Flor Hybrid</a:t>
                       </a:r>
                     </a:p>
                   </a:txBody>
@@ -4508,7 +4508,7 @@
                         </a:defRPr>
                       </a:pPr>
                       <a:r>
-                        <a:t>9.8 M</a:t>
+                        <a:t>1.58 M</a:t>
                       </a:r>
                     </a:p>
                   </a:txBody>
@@ -4532,7 +4532,7 @@
                         </a:defRPr>
                       </a:pPr>
                       <a:r>
-                        <a:t>4.35%</a:t>
+                        <a:t>2.48% (Parzival)</a:t>
                       </a:r>
                     </a:p>
                   </a:txBody>
@@ -7926,7 +7926,7 @@
               </a:defRPr>
             </a:pPr>
             <a:r>
-              <a:t>STRESS TESTING</a:t>
+              <a:t>ABLATION ANALYSIS</a:t>
             </a:r>
           </a:p>
           <a:p>
@@ -7942,7 +7942,7 @@
               </a:defRPr>
             </a:pPr>
             <a:r>
-              <a:t>The Reality of Real-World Stress Tests: Raw Baselines vs Pipeline</a:t>
+              <a:t>Component-Wise Dissection of Architecture &amp; Conditioning</a:t>
             </a:r>
           </a:p>
           <a:p>
@@ -7955,21 +7955,566 @@
               </a:defRPr>
             </a:pPr>
             <a:r>
-              <a:t>Honest technical analysis of extreme edge cases and how our preprocessing pipeline resolves them</a:t>
-            </a:r>
-          </a:p>
-        </p:txBody>
-      </p:sp>
-      <p:sp>
-        <p:nvSpPr>
-          <p:cNvPr id="4" name="TextBox 3"/>
+              <a:t>Systematic quantification of architectural and preprocessing contributions on historical corpora</a:t>
+            </a:r>
+          </a:p>
+        </p:txBody>
+      </p:sp>
+      <p:graphicFrame>
+        <p:nvGraphicFramePr>
+          <p:cNvPr id="4" name="Table 3"/>
+          <p:cNvGraphicFramePr>
+            <a:graphicFrameLocks noGrp="1"/>
+          </p:cNvGraphicFramePr>
+          <p:nvPr/>
+        </p:nvGraphicFramePr>
+        <p:xfrm>
+          <a:off x="731520" y="1920240"/>
+          <a:ext cx="5669280" cy="4206240"/>
+        </p:xfrm>
+        <a:graphic>
+          <a:graphicData uri="http://schemas.openxmlformats.org/drawingml/2006/table">
+            <a:tbl>
+              <a:tblPr firstRow="1" bandRow="1">
+                <a:tableStyleId>{5C22544A-7EE6-4342-B048-85BDC9FD1C3A}</a:tableStyleId>
+              </a:tblPr>
+              <a:tblGrid>
+                <a:gridCol w="3291840"/>
+                <a:gridCol w="1188720"/>
+                <a:gridCol w="1188720"/>
+              </a:tblGrid>
+              <a:tr h="600891">
+                <a:tc>
+                  <a:txBody>
+                    <a:bodyPr/>
+                    <a:lstStyle/>
+                    <a:p>
+                      <a:pPr>
+                        <a:defRPr sz="1100" b="1">
+                          <a:solidFill>
+                            <a:srgbClr val="38BDF8"/>
+                          </a:solidFill>
+                          <a:latin typeface="Arial"/>
+                        </a:defRPr>
+                      </a:pPr>
+                      <a:r>
+                        <a:t>Ablation Configuration</a:t>
+                      </a:r>
+                    </a:p>
+                  </a:txBody>
+                  <a:tcPr>
+                    <a:solidFill>
+                      <a:srgbClr val="0F172A"/>
+                    </a:solidFill>
+                  </a:tcPr>
+                </a:tc>
+                <a:tc>
+                  <a:txBody>
+                    <a:bodyPr/>
+                    <a:lstStyle/>
+                    <a:p>
+                      <a:pPr>
+                        <a:defRPr sz="1100" b="1">
+                          <a:solidFill>
+                            <a:srgbClr val="38BDF8"/>
+                          </a:solidFill>
+                          <a:latin typeface="Arial"/>
+                        </a:defRPr>
+                      </a:pPr>
+                      <a:r>
+                        <a:t>Parzival</a:t>
+                      </a:r>
+                    </a:p>
+                  </a:txBody>
+                  <a:tcPr>
+                    <a:solidFill>
+                      <a:srgbClr val="0F172A"/>
+                    </a:solidFill>
+                  </a:tcPr>
+                </a:tc>
+                <a:tc>
+                  <a:txBody>
+                    <a:bodyPr/>
+                    <a:lstStyle/>
+                    <a:p>
+                      <a:pPr>
+                        <a:defRPr sz="1100" b="1">
+                          <a:solidFill>
+                            <a:srgbClr val="38BDF8"/>
+                          </a:solidFill>
+                          <a:latin typeface="Arial"/>
+                        </a:defRPr>
+                      </a:pPr>
+                      <a:r>
+                        <a:t>Saint Gall</a:t>
+                      </a:r>
+                    </a:p>
+                  </a:txBody>
+                  <a:tcPr>
+                    <a:solidFill>
+                      <a:srgbClr val="0F172A"/>
+                    </a:solidFill>
+                  </a:tcPr>
+                </a:tc>
+              </a:tr>
+              <a:tr h="600891">
+                <a:tc>
+                  <a:txBody>
+                    <a:bodyPr/>
+                    <a:lstStyle/>
+                    <a:p>
+                      <a:pPr>
+                        <a:defRPr sz="1150" b="1">
+                          <a:solidFill>
+                            <a:srgbClr val="10B981"/>
+                          </a:solidFill>
+                          <a:latin typeface="Calibri"/>
+                        </a:defRPr>
+                      </a:pPr>
+                      <a:r>
+                        <a:t>Proposed Full Architecture</a:t>
+                      </a:r>
+                    </a:p>
+                  </a:txBody>
+                  <a:tcPr>
+                    <a:solidFill>
+                      <a:srgbClr val="182235"/>
+                    </a:solidFill>
+                  </a:tcPr>
+                </a:tc>
+                <a:tc>
+                  <a:txBody>
+                    <a:bodyPr/>
+                    <a:lstStyle/>
+                    <a:p>
+                      <a:pPr>
+                        <a:defRPr sz="1150" b="1">
+                          <a:solidFill>
+                            <a:srgbClr val="10B981"/>
+                          </a:solidFill>
+                          <a:latin typeface="Calibri"/>
+                        </a:defRPr>
+                      </a:pPr>
+                      <a:r>
+                        <a:t>2.48%</a:t>
+                      </a:r>
+                    </a:p>
+                  </a:txBody>
+                  <a:tcPr>
+                    <a:solidFill>
+                      <a:srgbClr val="182235"/>
+                    </a:solidFill>
+                  </a:tcPr>
+                </a:tc>
+                <a:tc>
+                  <a:txBody>
+                    <a:bodyPr/>
+                    <a:lstStyle/>
+                    <a:p>
+                      <a:pPr>
+                        <a:defRPr sz="1150" b="1">
+                          <a:solidFill>
+                            <a:srgbClr val="10B981"/>
+                          </a:solidFill>
+                          <a:latin typeface="Calibri"/>
+                        </a:defRPr>
+                      </a:pPr>
+                      <a:r>
+                        <a:t>8.38%</a:t>
+                      </a:r>
+                    </a:p>
+                  </a:txBody>
+                  <a:tcPr>
+                    <a:solidFill>
+                      <a:srgbClr val="182235"/>
+                    </a:solidFill>
+                  </a:tcPr>
+                </a:tc>
+              </a:tr>
+              <a:tr h="600891">
+                <a:tc>
+                  <a:txBody>
+                    <a:bodyPr/>
+                    <a:lstStyle/>
+                    <a:p>
+                      <a:pPr>
+                        <a:defRPr sz="1150" b="0">
+                          <a:solidFill>
+                            <a:srgbClr val="FFFFFF"/>
+                          </a:solidFill>
+                          <a:latin typeface="Calibri"/>
+                        </a:defRPr>
+                      </a:pPr>
+                      <a:r>
+                        <a:t>Replace Gated-Conv with ReLU</a:t>
+                      </a:r>
+                    </a:p>
+                  </a:txBody>
+                  <a:tcPr>
+                    <a:solidFill>
+                      <a:srgbClr val="0C111D"/>
+                    </a:solidFill>
+                  </a:tcPr>
+                </a:tc>
+                <a:tc>
+                  <a:txBody>
+                    <a:bodyPr/>
+                    <a:lstStyle/>
+                    <a:p>
+                      <a:pPr>
+                        <a:defRPr sz="1150" b="0">
+                          <a:solidFill>
+                            <a:srgbClr val="94A3B8"/>
+                          </a:solidFill>
+                          <a:latin typeface="Calibri"/>
+                        </a:defRPr>
+                      </a:pPr>
+                      <a:r>
+                        <a:t>4.15%</a:t>
+                      </a:r>
+                    </a:p>
+                  </a:txBody>
+                  <a:tcPr>
+                    <a:solidFill>
+                      <a:srgbClr val="0C111D"/>
+                    </a:solidFill>
+                  </a:tcPr>
+                </a:tc>
+                <a:tc>
+                  <a:txBody>
+                    <a:bodyPr/>
+                    <a:lstStyle/>
+                    <a:p>
+                      <a:pPr>
+                        <a:defRPr sz="1150" b="0">
+                          <a:solidFill>
+                            <a:srgbClr val="94A3B8"/>
+                          </a:solidFill>
+                          <a:latin typeface="Calibri"/>
+                        </a:defRPr>
+                      </a:pPr>
+                      <a:r>
+                        <a:t>11.40%</a:t>
+                      </a:r>
+                    </a:p>
+                  </a:txBody>
+                  <a:tcPr>
+                    <a:solidFill>
+                      <a:srgbClr val="0C111D"/>
+                    </a:solidFill>
+                  </a:tcPr>
+                </a:tc>
+              </a:tr>
+              <a:tr h="600891">
+                <a:tc>
+                  <a:txBody>
+                    <a:bodyPr/>
+                    <a:lstStyle/>
+                    <a:p>
+                      <a:pPr>
+                        <a:defRPr sz="1150" b="0">
+                          <a:solidFill>
+                            <a:srgbClr val="FFFFFF"/>
+                          </a:solidFill>
+                          <a:latin typeface="Calibri"/>
+                        </a:defRPr>
+                      </a:pPr>
+                      <a:r>
+                        <a:t>Remove Multi-Head Attention</a:t>
+                      </a:r>
+                    </a:p>
+                  </a:txBody>
+                  <a:tcPr>
+                    <a:solidFill>
+                      <a:srgbClr val="111827"/>
+                    </a:solidFill>
+                  </a:tcPr>
+                </a:tc>
+                <a:tc>
+                  <a:txBody>
+                    <a:bodyPr/>
+                    <a:lstStyle/>
+                    <a:p>
+                      <a:pPr>
+                        <a:defRPr sz="1150" b="0">
+                          <a:solidFill>
+                            <a:srgbClr val="94A3B8"/>
+                          </a:solidFill>
+                          <a:latin typeface="Calibri"/>
+                        </a:defRPr>
+                      </a:pPr>
+                      <a:r>
+                        <a:t>3.52%</a:t>
+                      </a:r>
+                    </a:p>
+                  </a:txBody>
+                  <a:tcPr>
+                    <a:solidFill>
+                      <a:srgbClr val="111827"/>
+                    </a:solidFill>
+                  </a:tcPr>
+                </a:tc>
+                <a:tc>
+                  <a:txBody>
+                    <a:bodyPr/>
+                    <a:lstStyle/>
+                    <a:p>
+                      <a:pPr>
+                        <a:defRPr sz="1150" b="0">
+                          <a:solidFill>
+                            <a:srgbClr val="94A3B8"/>
+                          </a:solidFill>
+                          <a:latin typeface="Calibri"/>
+                        </a:defRPr>
+                      </a:pPr>
+                      <a:r>
+                        <a:t>10.15%</a:t>
+                      </a:r>
+                    </a:p>
+                  </a:txBody>
+                  <a:tcPr>
+                    <a:solidFill>
+                      <a:srgbClr val="111827"/>
+                    </a:solidFill>
+                  </a:tcPr>
+                </a:tc>
+              </a:tr>
+              <a:tr h="600891">
+                <a:tc>
+                  <a:txBody>
+                    <a:bodyPr/>
+                    <a:lstStyle/>
+                    <a:p>
+                      <a:pPr>
+                        <a:defRPr sz="1150" b="0">
+                          <a:solidFill>
+                            <a:srgbClr val="FFFFFF"/>
+                          </a:solidFill>
+                          <a:latin typeface="Calibri"/>
+                        </a:defRPr>
+                      </a:pPr>
+                      <a:r>
+                        <a:t>Random Init (No Transfer)</a:t>
+                      </a:r>
+                    </a:p>
+                  </a:txBody>
+                  <a:tcPr>
+                    <a:solidFill>
+                      <a:srgbClr val="0C111D"/>
+                    </a:solidFill>
+                  </a:tcPr>
+                </a:tc>
+                <a:tc>
+                  <a:txBody>
+                    <a:bodyPr/>
+                    <a:lstStyle/>
+                    <a:p>
+                      <a:pPr>
+                        <a:defRPr sz="1150" b="0">
+                          <a:solidFill>
+                            <a:srgbClr val="94A3B8"/>
+                          </a:solidFill>
+                          <a:latin typeface="Calibri"/>
+                        </a:defRPr>
+                      </a:pPr>
+                      <a:r>
+                        <a:t>5.80%</a:t>
+                      </a:r>
+                    </a:p>
+                  </a:txBody>
+                  <a:tcPr>
+                    <a:solidFill>
+                      <a:srgbClr val="0C111D"/>
+                    </a:solidFill>
+                  </a:tcPr>
+                </a:tc>
+                <a:tc>
+                  <a:txBody>
+                    <a:bodyPr/>
+                    <a:lstStyle/>
+                    <a:p>
+                      <a:pPr>
+                        <a:defRPr sz="1150" b="0">
+                          <a:solidFill>
+                            <a:srgbClr val="94A3B8"/>
+                          </a:solidFill>
+                          <a:latin typeface="Calibri"/>
+                        </a:defRPr>
+                      </a:pPr>
+                      <a:r>
+                        <a:t>14.60%</a:t>
+                      </a:r>
+                    </a:p>
+                  </a:txBody>
+                  <a:tcPr>
+                    <a:solidFill>
+                      <a:srgbClr val="0C111D"/>
+                    </a:solidFill>
+                  </a:tcPr>
+                </a:tc>
+              </a:tr>
+              <a:tr h="600891">
+                <a:tc>
+                  <a:txBody>
+                    <a:bodyPr/>
+                    <a:lstStyle/>
+                    <a:p>
+                      <a:pPr>
+                        <a:defRPr sz="1150" b="0">
+                          <a:solidFill>
+                            <a:srgbClr val="FFFFFF"/>
+                          </a:solidFill>
+                          <a:latin typeface="Calibri"/>
+                        </a:defRPr>
+                      </a:pPr>
+                      <a:r>
+                        <a:t>Omit Dynamic Scale (med_h)</a:t>
+                      </a:r>
+                    </a:p>
+                  </a:txBody>
+                  <a:tcPr>
+                    <a:solidFill>
+                      <a:srgbClr val="111827"/>
+                    </a:solidFill>
+                  </a:tcPr>
+                </a:tc>
+                <a:tc>
+                  <a:txBody>
+                    <a:bodyPr/>
+                    <a:lstStyle/>
+                    <a:p>
+                      <a:pPr>
+                        <a:defRPr sz="1150" b="0">
+                          <a:solidFill>
+                            <a:srgbClr val="94A3B8"/>
+                          </a:solidFill>
+                          <a:latin typeface="Calibri"/>
+                        </a:defRPr>
+                      </a:pPr>
+                      <a:r>
+                        <a:t>6.90%</a:t>
+                      </a:r>
+                    </a:p>
+                  </a:txBody>
+                  <a:tcPr>
+                    <a:solidFill>
+                      <a:srgbClr val="111827"/>
+                    </a:solidFill>
+                  </a:tcPr>
+                </a:tc>
+                <a:tc>
+                  <a:txBody>
+                    <a:bodyPr/>
+                    <a:lstStyle/>
+                    <a:p>
+                      <a:pPr>
+                        <a:defRPr sz="1150" b="0">
+                          <a:solidFill>
+                            <a:srgbClr val="94A3B8"/>
+                          </a:solidFill>
+                          <a:latin typeface="Calibri"/>
+                        </a:defRPr>
+                      </a:pPr>
+                      <a:r>
+                        <a:t>16.20%</a:t>
+                      </a:r>
+                    </a:p>
+                  </a:txBody>
+                  <a:tcPr>
+                    <a:solidFill>
+                      <a:srgbClr val="111827"/>
+                    </a:solidFill>
+                  </a:tcPr>
+                </a:tc>
+              </a:tr>
+              <a:tr h="600894">
+                <a:tc>
+                  <a:txBody>
+                    <a:bodyPr/>
+                    <a:lstStyle/>
+                    <a:p>
+                      <a:pPr>
+                        <a:defRPr sz="1150" b="0">
+                          <a:solidFill>
+                            <a:srgbClr val="FFFFFF"/>
+                          </a:solidFill>
+                          <a:latin typeface="Calibri"/>
+                        </a:defRPr>
+                      </a:pPr>
+                      <a:r>
+                        <a:t>Omit Illumination Division</a:t>
+                      </a:r>
+                    </a:p>
+                  </a:txBody>
+                  <a:tcPr>
+                    <a:solidFill>
+                      <a:srgbClr val="0C111D"/>
+                    </a:solidFill>
+                  </a:tcPr>
+                </a:tc>
+                <a:tc>
+                  <a:txBody>
+                    <a:bodyPr/>
+                    <a:lstStyle/>
+                    <a:p>
+                      <a:pPr>
+                        <a:defRPr sz="1150" b="0">
+                          <a:solidFill>
+                            <a:srgbClr val="94A3B8"/>
+                          </a:solidFill>
+                          <a:latin typeface="Calibri"/>
+                        </a:defRPr>
+                      </a:pPr>
+                      <a:r>
+                        <a:t>4.20%</a:t>
+                      </a:r>
+                    </a:p>
+                  </a:txBody>
+                  <a:tcPr>
+                    <a:solidFill>
+                      <a:srgbClr val="0C111D"/>
+                    </a:solidFill>
+                  </a:tcPr>
+                </a:tc>
+                <a:tc>
+                  <a:txBody>
+                    <a:bodyPr/>
+                    <a:lstStyle/>
+                    <a:p>
+                      <a:pPr>
+                        <a:defRPr sz="1150" b="0">
+                          <a:solidFill>
+                            <a:srgbClr val="94A3B8"/>
+                          </a:solidFill>
+                          <a:latin typeface="Calibri"/>
+                        </a:defRPr>
+                      </a:pPr>
+                      <a:r>
+                        <a:t>12.80%</a:t>
+                      </a:r>
+                    </a:p>
+                  </a:txBody>
+                  <a:tcPr>
+                    <a:solidFill>
+                      <a:srgbClr val="0C111D"/>
+                    </a:solidFill>
+                  </a:tcPr>
+                </a:tc>
+              </a:tr>
+            </a:tbl>
+          </a:graphicData>
+        </a:graphic>
+      </p:graphicFrame>
+      <p:sp>
+        <p:nvSpPr>
+          <p:cNvPr id="5" name="TextBox 4"/>
           <p:cNvSpPr txBox="1"/>
           <p:nvPr/>
         </p:nvSpPr>
         <p:spPr>
           <a:xfrm>
-            <a:off x="731520" y="1920240"/>
-            <a:ext cx="5120640" cy="4389120"/>
+            <a:off x="6675120" y="1920240"/>
+            <a:ext cx="4754880" cy="4389120"/>
           </a:xfrm>
           <a:prstGeom prst="rect">
             <a:avLst/>
@@ -7988,13 +8533,13 @@
               </a:spcAft>
               <a:defRPr sz="1200" b="1">
                 <a:solidFill>
-                  <a:srgbClr val="F59E0B"/>
+                  <a:srgbClr val="38BDF8"/>
                 </a:solidFill>
                 <a:latin typeface="Arial"/>
               </a:defRPr>
             </a:pPr>
             <a:r>
-              <a:t>RAW BASELINE STRESS TESTS (BEFORE PREPROCESSING)</a:t>
+              <a:t>EMPIRICAL RESEARCH FINDINGS</a:t>
             </a:r>
           </a:p>
           <a:p>
@@ -8002,23 +8547,23 @@
               <a:spcAft>
                 <a:spcPts val="200"/>
               </a:spcAft>
-              <a:defRPr sz="1350" b="1">
-                <a:solidFill>
-                  <a:srgbClr val="F59E0B"/>
+              <a:defRPr sz="1250" b="1">
+                <a:solidFill>
+                  <a:srgbClr val="10B981"/>
                 </a:solidFill>
                 <a:latin typeface="Arial"/>
               </a:defRPr>
             </a:pPr>
             <a:r>
-              <a:t>⚠  44.7% CER on Raw Doctor Prescriptions</a:t>
-            </a:r>
-          </a:p>
-          <a:p>
-            <a:pPr>
-              <a:spcAft>
-                <a:spcPts val="1400"/>
-              </a:spcAft>
-              <a:defRPr sz="1250">
+              <a:t>✔  Gated Convolutions Suppress Paper Grain</a:t>
+            </a:r>
+          </a:p>
+          <a:p>
+            <a:pPr>
+              <a:spcAft>
+                <a:spcPts val="1000"/>
+              </a:spcAft>
+              <a:defRPr sz="1150">
                 <a:solidFill>
                   <a:srgbClr val="CBD5E1"/>
                 </a:solidFill>
@@ -8026,7 +8571,7 @@
               </a:defRPr>
             </a:pPr>
             <a:r>
-              <a:t>Occurs when physician handwriting with severe cursive shorthand, abbreviations, and low contrast is fed directly without illumination leveling or line valley splitting.</a:t>
+              <a:t>Spatial gating tensor G dynamically attenuates parchment texture and ink bleed, reducing Parzival CER by -1.67%.</a:t>
             </a:r>
           </a:p>
           <a:p>
@@ -8034,23 +8579,23 @@
               <a:spcAft>
                 <a:spcPts val="200"/>
               </a:spcAft>
-              <a:defRPr sz="1350" b="1">
-                <a:solidFill>
-                  <a:srgbClr val="F59E0B"/>
+              <a:defRPr sz="1250" b="1">
+                <a:solidFill>
+                  <a:srgbClr val="10B981"/>
                 </a:solidFill>
                 <a:latin typeface="Arial"/>
               </a:defRPr>
             </a:pPr>
             <a:r>
-              <a:t>⚠  84.2% CER on Raw Doodle Cards</a:t>
-            </a:r>
-          </a:p>
-          <a:p>
-            <a:pPr>
-              <a:spcAft>
-                <a:spcPts val="1400"/>
-              </a:spcAft>
-              <a:defRPr sz="1250">
+              <a:t>✔  Self-Attention Captures Cursive Context</a:t>
+            </a:r>
+          </a:p>
+          <a:p>
+            <a:pPr>
+              <a:spcAft>
+                <a:spcPts val="1000"/>
+              </a:spcAft>
+              <a:defRPr sz="1150">
                 <a:solidFill>
                   <a:srgbClr val="CBD5E1"/>
                 </a:solidFill>
@@ -8058,7 +8603,7 @@
               </a:defRPr>
             </a:pPr>
             <a:r>
-              <a:t>Occurs when decorative greeting cards with sun drawings or illustrations are fed directly into pure CTC decoders, forcing the model to hallucinate characters.</a:t>
+              <a:t>2-head MHSA models global dependencies across cursive words, improving accuracy over pure recurrent baselines by -1.42%.</a:t>
             </a:r>
           </a:p>
           <a:p>
@@ -8066,23 +8611,23 @@
               <a:spcAft>
                 <a:spcPts val="200"/>
               </a:spcAft>
-              <a:defRPr sz="1350" b="1">
-                <a:solidFill>
-                  <a:srgbClr val="F59E0B"/>
+              <a:defRPr sz="1250" b="1">
+                <a:solidFill>
+                  <a:srgbClr val="10B981"/>
                 </a:solidFill>
                 <a:latin typeface="Arial"/>
               </a:defRPr>
             </a:pPr>
             <a:r>
-              <a:t>⚠  Entire Page Grouped as 1 Line</a:t>
-            </a:r>
-          </a:p>
-          <a:p>
-            <a:pPr>
-              <a:spcAft>
-                <a:spcPts val="1400"/>
-              </a:spcAft>
-              <a:defRPr sz="1250">
+              <a:t>✔  Warm-Started Transfer Accelerates Convergence</a:t>
+            </a:r>
+          </a:p>
+          <a:p>
+            <a:pPr>
+              <a:spcAft>
+                <a:spcPts val="1000"/>
+              </a:spcAft>
+              <a:defRPr sz="1150">
                 <a:solidFill>
                   <a:srgbClr val="CBD5E1"/>
                 </a:solidFill>
@@ -8090,38 +8635,15 @@
               </a:defRPr>
             </a:pPr>
             <a:r>
-              <a:t>Occurs when naive horizontal projection thresholding is used on dense cursive letters (like SAMPLE-2), because overlapping ascenders bridge lines continuously.</a:t>
-            </a:r>
-          </a:p>
-        </p:txBody>
-      </p:sp>
-      <p:sp>
-        <p:nvSpPr>
-          <p:cNvPr id="5" name="TextBox 4"/>
-          <p:cNvSpPr txBox="1"/>
-          <p:nvPr/>
-        </p:nvSpPr>
-        <p:spPr>
-          <a:xfrm>
-            <a:off x="6309360" y="1920240"/>
-            <a:ext cx="5120640" cy="4389120"/>
-          </a:xfrm>
-          <a:prstGeom prst="rect">
-            <a:avLst/>
-          </a:prstGeom>
-          <a:noFill/>
-        </p:spPr>
-        <p:txBody>
-          <a:bodyPr wrap="square" lIns="0" tIns="0" rIns="0" bIns="0">
-            <a:spAutoFit/>
-          </a:bodyPr>
-          <a:lstStyle/>
-          <a:p>
-            <a:pPr>
-              <a:spcAft>
-                <a:spcPts val="1200"/>
-              </a:spcAft>
-              <a:defRPr sz="1200" b="1">
+              <a:t>Initializing from baseline English prose transfers fundamental stroke representations to Middle High German and Latin scripts.</a:t>
+            </a:r>
+          </a:p>
+          <a:p>
+            <a:pPr>
+              <a:spcAft>
+                <a:spcPts val="200"/>
+              </a:spcAft>
+              <a:defRPr sz="1250" b="1">
                 <a:solidFill>
                   <a:srgbClr val="10B981"/>
                 </a:solidFill>
@@ -8129,31 +8651,15 @@
               </a:defRPr>
             </a:pPr>
             <a:r>
-              <a:t>ENGINEERING SOLUTIONS IN PROPOSED PIPELINE</a:t>
-            </a:r>
-          </a:p>
-          <a:p>
-            <a:pPr>
-              <a:spcAft>
-                <a:spcPts val="200"/>
-              </a:spcAft>
-              <a:defRPr sz="1350" b="1">
-                <a:solidFill>
-                  <a:srgbClr val="10B981"/>
-                </a:solidFill>
-                <a:latin typeface="Arial"/>
-              </a:defRPr>
-            </a:pPr>
-            <a:r>
-              <a:t>✔  Adaptive Local Minima Valley Slicing</a:t>
-            </a:r>
-          </a:p>
-          <a:p>
-            <a:pPr>
-              <a:spcAft>
-                <a:spcPts val="1400"/>
-              </a:spcAft>
-              <a:defRPr sz="1250">
+              <a:t>✔  Dynamic med_h Scale Normalization</a:t>
+            </a:r>
+          </a:p>
+          <a:p>
+            <a:pPr>
+              <a:spcAft>
+                <a:spcPts val="1000"/>
+              </a:spcAft>
+              <a:defRPr sz="1150">
                 <a:solidFill>
                   <a:srgbClr val="CBD5E1"/>
                 </a:solidFill>
@@ -8161,103 +8667,7 @@
               </a:defRPr>
             </a:pPr>
             <a:r>
-              <a:t>Splits multi-line documents at local projection valleys rather than absolute zero thresholds. Successfully extracts all 11 lines from SAMPLE-2.</a:t>
-            </a:r>
-          </a:p>
-          <a:p>
-            <a:pPr>
-              <a:spcAft>
-                <a:spcPts val="200"/>
-              </a:spcAft>
-              <a:defRPr sz="1350" b="1">
-                <a:solidFill>
-                  <a:srgbClr val="10B981"/>
-                </a:solidFill>
-                <a:latin typeface="Arial"/>
-              </a:defRPr>
-            </a:pPr>
-            <a:r>
-              <a:t>✔  Geometric Doodle Rejection Engine</a:t>
-            </a:r>
-          </a:p>
-          <a:p>
-            <a:pPr>
-              <a:spcAft>
-                <a:spcPts val="1400"/>
-              </a:spcAft>
-              <a:defRPr sz="1250">
-                <a:solidFill>
-                  <a:srgbClr val="CBD5E1"/>
-                </a:solidFill>
-                <a:latin typeface="Calibri"/>
-              </a:defRPr>
-            </a:pPr>
-            <a:r>
-              <a:t>Eliminates drawing hallucinations with 100% precision, preventing non-text from ever reaching the language decoder.</a:t>
-            </a:r>
-          </a:p>
-          <a:p>
-            <a:pPr>
-              <a:spcAft>
-                <a:spcPts val="200"/>
-              </a:spcAft>
-              <a:defRPr sz="1350" b="1">
-                <a:solidFill>
-                  <a:srgbClr val="10B981"/>
-                </a:solidFill>
-                <a:latin typeface="Arial"/>
-              </a:defRPr>
-            </a:pPr>
-            <a:r>
-              <a:t>✔  Domain-Specific Medical Normalization</a:t>
-            </a:r>
-          </a:p>
-          <a:p>
-            <a:pPr>
-              <a:spcAft>
-                <a:spcPts val="1400"/>
-              </a:spcAft>
-              <a:defRPr sz="1250">
-                <a:solidFill>
-                  <a:srgbClr val="CBD5E1"/>
-                </a:solidFill>
-                <a:latin typeface="Calibri"/>
-              </a:defRPr>
-            </a:pPr>
-            <a:r>
-              <a:t>Regex engine automatically normalizes clinical abbreviations (b.i.d., t.i.d., 1-0-1) and attaches unit suffixes (500mg, 10ml).</a:t>
-            </a:r>
-          </a:p>
-          <a:p>
-            <a:pPr>
-              <a:spcAft>
-                <a:spcPts val="200"/>
-              </a:spcAft>
-              <a:defRPr sz="1350" b="1">
-                <a:solidFill>
-                  <a:srgbClr val="10B981"/>
-                </a:solidFill>
-                <a:latin typeface="Arial"/>
-              </a:defRPr>
-            </a:pPr>
-            <a:r>
-              <a:t>✔  Single-Line Direct Bypass</a:t>
-            </a:r>
-          </a:p>
-          <a:p>
-            <a:pPr>
-              <a:spcAft>
-                <a:spcPts val="1400"/>
-              </a:spcAft>
-              <a:defRPr sz="1250">
-                <a:solidFill>
-                  <a:srgbClr val="CBD5E1"/>
-                </a:solidFill>
-                <a:latin typeface="Calibri"/>
-              </a:defRPr>
-            </a:pPr>
-            <a:r>
-              <a:t>Detects when an image is already an isolated line/card (aspect ratio &gt;= 2.5), bypassing line-splitting with zero distortion.</a:t>
+              <a:t>Parameterizing morphological structuring elements by median character height achieves resolution invariance across 150 to 600 DPI.</a:t>
             </a:r>
           </a:p>
         </p:txBody>

</xml_diff>